<commit_message>
fix(docs): update last version of presentation file
</commit_message>
<xml_diff>
--- a/docs/Presentation_PFA_LogAnalyze_Final.pptx
+++ b/docs/Presentation_PFA_LogAnalyze_Final.pptx
@@ -5,18 +5,18 @@
     <p:sldMasterId id="2147483648" r:id="rId1"/>
   </p:sldMasterIdLst>
   <p:sldIdLst>
-    <p:sldId id="256" r:id="rId7"/>
-    <p:sldId id="257" r:id="rId8"/>
-    <p:sldId id="258" r:id="rId9"/>
-    <p:sldId id="259" r:id="rId10"/>
-    <p:sldId id="260" r:id="rId11"/>
-    <p:sldId id="261" r:id="rId12"/>
-    <p:sldId id="262" r:id="rId13"/>
-    <p:sldId id="263" r:id="rId14"/>
-    <p:sldId id="264" r:id="rId15"/>
-    <p:sldId id="265" r:id="rId16"/>
+    <p:sldId id="256" r:id="rId2"/>
+    <p:sldId id="257" r:id="rId3"/>
+    <p:sldId id="258" r:id="rId4"/>
+    <p:sldId id="259" r:id="rId5"/>
+    <p:sldId id="260" r:id="rId6"/>
+    <p:sldId id="261" r:id="rId7"/>
+    <p:sldId id="262" r:id="rId8"/>
+    <p:sldId id="263" r:id="rId9"/>
+    <p:sldId id="264" r:id="rId10"/>
+    <p:sldId id="265" r:id="rId11"/>
   </p:sldIdLst>
-  <p:sldSz cx="12191695" cy="6858000" type="screen4x3"/>
+  <p:sldSz cx="12192000" cy="6858000"/>
   <p:notesSz cx="6858000" cy="9144000"/>
   <p:defaultTextStyle>
     <a:defPPr>
@@ -113,6 +113,22 @@
       </a:defRPr>
     </a:lvl9pPr>
   </p:defaultTextStyle>
+  <p:extLst>
+    <p:ext uri="{EFAFB233-063F-42B5-8137-9DF3F51BA10A}">
+      <p15:sldGuideLst xmlns:p15="http://schemas.microsoft.com/office/powerpoint/2012/main">
+        <p15:guide id="1" orient="horz" pos="2160">
+          <p15:clr>
+            <a:srgbClr val="A4A3A4"/>
+          </p15:clr>
+        </p15:guide>
+        <p15:guide id="2" pos="2880">
+          <p15:clr>
+            <a:srgbClr val="A4A3A4"/>
+          </p15:clr>
+        </p15:guide>
+      </p15:sldGuideLst>
+    </p:ext>
+  </p:extLst>
 </p:presentation>
 </file>
 
@@ -154,10 +170,9 @@
           <a:lstStyle/>
           <a:p>
             <a:r>
-              <a:rPr lang="en-US" smtClean="0"/>
+              <a:rPr lang="en-US"/>
               <a:t>Click to edit Master title style</a:t>
             </a:r>
-            <a:endParaRPr lang="en-US"/>
           </a:p>
         </p:txBody>
       </p:sp>
@@ -273,10 +288,9 @@
           </a:lstStyle>
           <a:p>
             <a:r>
-              <a:rPr lang="en-US" smtClean="0"/>
+              <a:rPr lang="en-US"/>
               <a:t>Click to edit Master subtitle style</a:t>
             </a:r>
-            <a:endParaRPr lang="en-US"/>
           </a:p>
         </p:txBody>
       </p:sp>
@@ -297,7 +311,7 @@
           <a:p>
             <a:fld id="{5BCAD085-E8A6-8845-BD4E-CB4CCA059FC4}" type="datetimeFigureOut">
               <a:rPr lang="en-US" smtClean="0"/>
-              <a:t>1/27/13</a:t>
+              <a:t>9/14/2026</a:t>
             </a:fld>
             <a:endParaRPr lang="en-US"/>
           </a:p>
@@ -339,7 +353,7 @@
           <a:p>
             <a:fld id="{C1FF6DA9-008F-8B48-92A6-B652298478BF}" type="slidenum">
               <a:rPr lang="en-US" smtClean="0"/>
-              <a:t>‹#›</a:t>
+              <a:t>‹N°›</a:t>
             </a:fld>
             <a:endParaRPr lang="en-US"/>
           </a:p>
@@ -391,10 +405,9 @@
           <a:lstStyle/>
           <a:p>
             <a:r>
-              <a:rPr lang="en-US" smtClean="0"/>
+              <a:rPr lang="en-US"/>
               <a:t>Click to edit Master title style</a:t>
             </a:r>
-            <a:endParaRPr lang="en-US"/>
           </a:p>
         </p:txBody>
       </p:sp>
@@ -415,38 +428,37 @@
           <a:p>
             <a:pPr lvl="0"/>
             <a:r>
-              <a:rPr lang="en-US" smtClean="0"/>
+              <a:rPr lang="en-US"/>
               <a:t>Click to edit Master text styles</a:t>
             </a:r>
           </a:p>
           <a:p>
             <a:pPr lvl="1"/>
             <a:r>
-              <a:rPr lang="en-US" smtClean="0"/>
+              <a:rPr lang="en-US"/>
               <a:t>Second level</a:t>
             </a:r>
           </a:p>
           <a:p>
             <a:pPr lvl="2"/>
             <a:r>
-              <a:rPr lang="en-US" smtClean="0"/>
+              <a:rPr lang="en-US"/>
               <a:t>Third level</a:t>
             </a:r>
           </a:p>
           <a:p>
             <a:pPr lvl="3"/>
             <a:r>
-              <a:rPr lang="en-US" smtClean="0"/>
+              <a:rPr lang="en-US"/>
               <a:t>Fourth level</a:t>
             </a:r>
           </a:p>
           <a:p>
             <a:pPr lvl="4"/>
             <a:r>
-              <a:rPr lang="en-US" smtClean="0"/>
+              <a:rPr lang="en-US"/>
               <a:t>Fifth level</a:t>
             </a:r>
-            <a:endParaRPr lang="en-US"/>
           </a:p>
         </p:txBody>
       </p:sp>
@@ -467,7 +479,7 @@
           <a:p>
             <a:fld id="{5BCAD085-E8A6-8845-BD4E-CB4CCA059FC4}" type="datetimeFigureOut">
               <a:rPr lang="en-US" smtClean="0"/>
-              <a:t>1/27/13</a:t>
+              <a:t>9/14/2026</a:t>
             </a:fld>
             <a:endParaRPr lang="en-US"/>
           </a:p>
@@ -509,7 +521,7 @@
           <a:p>
             <a:fld id="{C1FF6DA9-008F-8B48-92A6-B652298478BF}" type="slidenum">
               <a:rPr lang="en-US" smtClean="0"/>
-              <a:t>‹#›</a:t>
+              <a:t>‹N°›</a:t>
             </a:fld>
             <a:endParaRPr lang="en-US"/>
           </a:p>
@@ -566,10 +578,9 @@
           <a:lstStyle/>
           <a:p>
             <a:r>
-              <a:rPr lang="en-US" smtClean="0"/>
+              <a:rPr lang="en-US"/>
               <a:t>Click to edit Master title style</a:t>
             </a:r>
-            <a:endParaRPr lang="en-US"/>
           </a:p>
         </p:txBody>
       </p:sp>
@@ -595,38 +606,37 @@
           <a:p>
             <a:pPr lvl="0"/>
             <a:r>
-              <a:rPr lang="en-US" smtClean="0"/>
+              <a:rPr lang="en-US"/>
               <a:t>Click to edit Master text styles</a:t>
             </a:r>
           </a:p>
           <a:p>
             <a:pPr lvl="1"/>
             <a:r>
-              <a:rPr lang="en-US" smtClean="0"/>
+              <a:rPr lang="en-US"/>
               <a:t>Second level</a:t>
             </a:r>
           </a:p>
           <a:p>
             <a:pPr lvl="2"/>
             <a:r>
-              <a:rPr lang="en-US" smtClean="0"/>
+              <a:rPr lang="en-US"/>
               <a:t>Third level</a:t>
             </a:r>
           </a:p>
           <a:p>
             <a:pPr lvl="3"/>
             <a:r>
-              <a:rPr lang="en-US" smtClean="0"/>
+              <a:rPr lang="en-US"/>
               <a:t>Fourth level</a:t>
             </a:r>
           </a:p>
           <a:p>
             <a:pPr lvl="4"/>
             <a:r>
-              <a:rPr lang="en-US" smtClean="0"/>
+              <a:rPr lang="en-US"/>
               <a:t>Fifth level</a:t>
             </a:r>
-            <a:endParaRPr lang="en-US"/>
           </a:p>
         </p:txBody>
       </p:sp>
@@ -647,7 +657,7 @@
           <a:p>
             <a:fld id="{5BCAD085-E8A6-8845-BD4E-CB4CCA059FC4}" type="datetimeFigureOut">
               <a:rPr lang="en-US" smtClean="0"/>
-              <a:t>1/27/13</a:t>
+              <a:t>9/14/2026</a:t>
             </a:fld>
             <a:endParaRPr lang="en-US"/>
           </a:p>
@@ -689,7 +699,7 @@
           <a:p>
             <a:fld id="{C1FF6DA9-008F-8B48-92A6-B652298478BF}" type="slidenum">
               <a:rPr lang="en-US" smtClean="0"/>
-              <a:t>‹#›</a:t>
+              <a:t>‹N°›</a:t>
             </a:fld>
             <a:endParaRPr lang="en-US"/>
           </a:p>
@@ -741,10 +751,9 @@
           <a:lstStyle/>
           <a:p>
             <a:r>
-              <a:rPr lang="en-US" smtClean="0"/>
+              <a:rPr lang="en-US"/>
               <a:t>Click to edit Master title style</a:t>
             </a:r>
-            <a:endParaRPr lang="en-US"/>
           </a:p>
         </p:txBody>
       </p:sp>
@@ -765,38 +774,37 @@
           <a:p>
             <a:pPr lvl="0"/>
             <a:r>
-              <a:rPr lang="en-US" smtClean="0"/>
+              <a:rPr lang="en-US"/>
               <a:t>Click to edit Master text styles</a:t>
             </a:r>
           </a:p>
           <a:p>
             <a:pPr lvl="1"/>
             <a:r>
-              <a:rPr lang="en-US" smtClean="0"/>
+              <a:rPr lang="en-US"/>
               <a:t>Second level</a:t>
             </a:r>
           </a:p>
           <a:p>
             <a:pPr lvl="2"/>
             <a:r>
-              <a:rPr lang="en-US" smtClean="0"/>
+              <a:rPr lang="en-US"/>
               <a:t>Third level</a:t>
             </a:r>
           </a:p>
           <a:p>
             <a:pPr lvl="3"/>
             <a:r>
-              <a:rPr lang="en-US" smtClean="0"/>
+              <a:rPr lang="en-US"/>
               <a:t>Fourth level</a:t>
             </a:r>
           </a:p>
           <a:p>
             <a:pPr lvl="4"/>
             <a:r>
-              <a:rPr lang="en-US" smtClean="0"/>
+              <a:rPr lang="en-US"/>
               <a:t>Fifth level</a:t>
             </a:r>
-            <a:endParaRPr lang="en-US"/>
           </a:p>
         </p:txBody>
       </p:sp>
@@ -817,7 +825,7 @@
           <a:p>
             <a:fld id="{5BCAD085-E8A6-8845-BD4E-CB4CCA059FC4}" type="datetimeFigureOut">
               <a:rPr lang="en-US" smtClean="0"/>
-              <a:t>1/27/13</a:t>
+              <a:t>9/14/2026</a:t>
             </a:fld>
             <a:endParaRPr lang="en-US"/>
           </a:p>
@@ -859,7 +867,7 @@
           <a:p>
             <a:fld id="{C1FF6DA9-008F-8B48-92A6-B652298478BF}" type="slidenum">
               <a:rPr lang="en-US" smtClean="0"/>
-              <a:t>‹#›</a:t>
+              <a:t>‹N°›</a:t>
             </a:fld>
             <a:endParaRPr lang="en-US"/>
           </a:p>
@@ -920,10 +928,9 @@
           </a:lstStyle>
           <a:p>
             <a:r>
-              <a:rPr lang="en-US" smtClean="0"/>
+              <a:rPr lang="en-US"/>
               <a:t>Click to edit Master title style</a:t>
             </a:r>
-            <a:endParaRPr lang="en-US"/>
           </a:p>
         </p:txBody>
       </p:sp>
@@ -1040,7 +1047,7 @@
           <a:p>
             <a:pPr lvl="0"/>
             <a:r>
-              <a:rPr lang="en-US" smtClean="0"/>
+              <a:rPr lang="en-US"/>
               <a:t>Click to edit Master text styles</a:t>
             </a:r>
           </a:p>
@@ -1063,7 +1070,7 @@
           <a:p>
             <a:fld id="{5BCAD085-E8A6-8845-BD4E-CB4CCA059FC4}" type="datetimeFigureOut">
               <a:rPr lang="en-US" smtClean="0"/>
-              <a:t>1/27/13</a:t>
+              <a:t>9/14/2026</a:t>
             </a:fld>
             <a:endParaRPr lang="en-US"/>
           </a:p>
@@ -1105,7 +1112,7 @@
           <a:p>
             <a:fld id="{C1FF6DA9-008F-8B48-92A6-B652298478BF}" type="slidenum">
               <a:rPr lang="en-US" smtClean="0"/>
-              <a:t>‹#›</a:t>
+              <a:t>‹N°›</a:t>
             </a:fld>
             <a:endParaRPr lang="en-US"/>
           </a:p>
@@ -1157,10 +1164,9 @@
           <a:lstStyle/>
           <a:p>
             <a:r>
-              <a:rPr lang="en-US" smtClean="0"/>
+              <a:rPr lang="en-US"/>
               <a:t>Click to edit Master title style</a:t>
             </a:r>
-            <a:endParaRPr lang="en-US"/>
           </a:p>
         </p:txBody>
       </p:sp>
@@ -1214,38 +1220,37 @@
           <a:p>
             <a:pPr lvl="0"/>
             <a:r>
-              <a:rPr lang="en-US" smtClean="0"/>
+              <a:rPr lang="en-US"/>
               <a:t>Click to edit Master text styles</a:t>
             </a:r>
           </a:p>
           <a:p>
             <a:pPr lvl="1"/>
             <a:r>
-              <a:rPr lang="en-US" smtClean="0"/>
+              <a:rPr lang="en-US"/>
               <a:t>Second level</a:t>
             </a:r>
           </a:p>
           <a:p>
             <a:pPr lvl="2"/>
             <a:r>
-              <a:rPr lang="en-US" smtClean="0"/>
+              <a:rPr lang="en-US"/>
               <a:t>Third level</a:t>
             </a:r>
           </a:p>
           <a:p>
             <a:pPr lvl="3"/>
             <a:r>
-              <a:rPr lang="en-US" smtClean="0"/>
+              <a:rPr lang="en-US"/>
               <a:t>Fourth level</a:t>
             </a:r>
           </a:p>
           <a:p>
             <a:pPr lvl="4"/>
             <a:r>
-              <a:rPr lang="en-US" smtClean="0"/>
+              <a:rPr lang="en-US"/>
               <a:t>Fifth level</a:t>
             </a:r>
-            <a:endParaRPr lang="en-US"/>
           </a:p>
         </p:txBody>
       </p:sp>
@@ -1299,38 +1304,37 @@
           <a:p>
             <a:pPr lvl="0"/>
             <a:r>
-              <a:rPr lang="en-US" smtClean="0"/>
+              <a:rPr lang="en-US"/>
               <a:t>Click to edit Master text styles</a:t>
             </a:r>
           </a:p>
           <a:p>
             <a:pPr lvl="1"/>
             <a:r>
-              <a:rPr lang="en-US" smtClean="0"/>
+              <a:rPr lang="en-US"/>
               <a:t>Second level</a:t>
             </a:r>
           </a:p>
           <a:p>
             <a:pPr lvl="2"/>
             <a:r>
-              <a:rPr lang="en-US" smtClean="0"/>
+              <a:rPr lang="en-US"/>
               <a:t>Third level</a:t>
             </a:r>
           </a:p>
           <a:p>
             <a:pPr lvl="3"/>
             <a:r>
-              <a:rPr lang="en-US" smtClean="0"/>
+              <a:rPr lang="en-US"/>
               <a:t>Fourth level</a:t>
             </a:r>
           </a:p>
           <a:p>
             <a:pPr lvl="4"/>
             <a:r>
-              <a:rPr lang="en-US" smtClean="0"/>
+              <a:rPr lang="en-US"/>
               <a:t>Fifth level</a:t>
             </a:r>
-            <a:endParaRPr lang="en-US"/>
           </a:p>
         </p:txBody>
       </p:sp>
@@ -1351,7 +1355,7 @@
           <a:p>
             <a:fld id="{5BCAD085-E8A6-8845-BD4E-CB4CCA059FC4}" type="datetimeFigureOut">
               <a:rPr lang="en-US" smtClean="0"/>
-              <a:t>1/27/13</a:t>
+              <a:t>9/14/2026</a:t>
             </a:fld>
             <a:endParaRPr lang="en-US"/>
           </a:p>
@@ -1393,7 +1397,7 @@
           <a:p>
             <a:fld id="{C1FF6DA9-008F-8B48-92A6-B652298478BF}" type="slidenum">
               <a:rPr lang="en-US" smtClean="0"/>
-              <a:t>‹#›</a:t>
+              <a:t>‹N°›</a:t>
             </a:fld>
             <a:endParaRPr lang="en-US"/>
           </a:p>
@@ -1449,10 +1453,9 @@
           </a:lstStyle>
           <a:p>
             <a:r>
-              <a:rPr lang="en-US" smtClean="0"/>
+              <a:rPr lang="en-US"/>
               <a:t>Click to edit Master title style</a:t>
             </a:r>
-            <a:endParaRPr lang="en-US"/>
           </a:p>
         </p:txBody>
       </p:sp>
@@ -1515,7 +1518,7 @@
           <a:p>
             <a:pPr lvl="0"/>
             <a:r>
-              <a:rPr lang="en-US" smtClean="0"/>
+              <a:rPr lang="en-US"/>
               <a:t>Click to edit Master text styles</a:t>
             </a:r>
           </a:p>
@@ -1571,38 +1574,37 @@
           <a:p>
             <a:pPr lvl="0"/>
             <a:r>
-              <a:rPr lang="en-US" smtClean="0"/>
+              <a:rPr lang="en-US"/>
               <a:t>Click to edit Master text styles</a:t>
             </a:r>
           </a:p>
           <a:p>
             <a:pPr lvl="1"/>
             <a:r>
-              <a:rPr lang="en-US" smtClean="0"/>
+              <a:rPr lang="en-US"/>
               <a:t>Second level</a:t>
             </a:r>
           </a:p>
           <a:p>
             <a:pPr lvl="2"/>
             <a:r>
-              <a:rPr lang="en-US" smtClean="0"/>
+              <a:rPr lang="en-US"/>
               <a:t>Third level</a:t>
             </a:r>
           </a:p>
           <a:p>
             <a:pPr lvl="3"/>
             <a:r>
-              <a:rPr lang="en-US" smtClean="0"/>
+              <a:rPr lang="en-US"/>
               <a:t>Fourth level</a:t>
             </a:r>
           </a:p>
           <a:p>
             <a:pPr lvl="4"/>
             <a:r>
-              <a:rPr lang="en-US" smtClean="0"/>
+              <a:rPr lang="en-US"/>
               <a:t>Fifth level</a:t>
             </a:r>
-            <a:endParaRPr lang="en-US"/>
           </a:p>
         </p:txBody>
       </p:sp>
@@ -1665,7 +1667,7 @@
           <a:p>
             <a:pPr lvl="0"/>
             <a:r>
-              <a:rPr lang="en-US" smtClean="0"/>
+              <a:rPr lang="en-US"/>
               <a:t>Click to edit Master text styles</a:t>
             </a:r>
           </a:p>
@@ -1721,38 +1723,37 @@
           <a:p>
             <a:pPr lvl="0"/>
             <a:r>
-              <a:rPr lang="en-US" smtClean="0"/>
+              <a:rPr lang="en-US"/>
               <a:t>Click to edit Master text styles</a:t>
             </a:r>
           </a:p>
           <a:p>
             <a:pPr lvl="1"/>
             <a:r>
-              <a:rPr lang="en-US" smtClean="0"/>
+              <a:rPr lang="en-US"/>
               <a:t>Second level</a:t>
             </a:r>
           </a:p>
           <a:p>
             <a:pPr lvl="2"/>
             <a:r>
-              <a:rPr lang="en-US" smtClean="0"/>
+              <a:rPr lang="en-US"/>
               <a:t>Third level</a:t>
             </a:r>
           </a:p>
           <a:p>
             <a:pPr lvl="3"/>
             <a:r>
-              <a:rPr lang="en-US" smtClean="0"/>
+              <a:rPr lang="en-US"/>
               <a:t>Fourth level</a:t>
             </a:r>
           </a:p>
           <a:p>
             <a:pPr lvl="4"/>
             <a:r>
-              <a:rPr lang="en-US" smtClean="0"/>
+              <a:rPr lang="en-US"/>
               <a:t>Fifth level</a:t>
             </a:r>
-            <a:endParaRPr lang="en-US"/>
           </a:p>
         </p:txBody>
       </p:sp>
@@ -1773,7 +1774,7 @@
           <a:p>
             <a:fld id="{5BCAD085-E8A6-8845-BD4E-CB4CCA059FC4}" type="datetimeFigureOut">
               <a:rPr lang="en-US" smtClean="0"/>
-              <a:t>1/27/13</a:t>
+              <a:t>9/14/2026</a:t>
             </a:fld>
             <a:endParaRPr lang="en-US"/>
           </a:p>
@@ -1815,7 +1816,7 @@
           <a:p>
             <a:fld id="{C1FF6DA9-008F-8B48-92A6-B652298478BF}" type="slidenum">
               <a:rPr lang="en-US" smtClean="0"/>
-              <a:t>‹#›</a:t>
+              <a:t>‹N°›</a:t>
             </a:fld>
             <a:endParaRPr lang="en-US"/>
           </a:p>
@@ -1867,10 +1868,9 @@
           <a:lstStyle/>
           <a:p>
             <a:r>
-              <a:rPr lang="en-US" smtClean="0"/>
+              <a:rPr lang="en-US"/>
               <a:t>Click to edit Master title style</a:t>
             </a:r>
-            <a:endParaRPr lang="en-US"/>
           </a:p>
         </p:txBody>
       </p:sp>
@@ -1891,7 +1891,7 @@
           <a:p>
             <a:fld id="{5BCAD085-E8A6-8845-BD4E-CB4CCA059FC4}" type="datetimeFigureOut">
               <a:rPr lang="en-US" smtClean="0"/>
-              <a:t>1/27/13</a:t>
+              <a:t>9/14/2026</a:t>
             </a:fld>
             <a:endParaRPr lang="en-US"/>
           </a:p>
@@ -1933,7 +1933,7 @@
           <a:p>
             <a:fld id="{C1FF6DA9-008F-8B48-92A6-B652298478BF}" type="slidenum">
               <a:rPr lang="en-US" smtClean="0"/>
-              <a:t>‹#›</a:t>
+              <a:t>‹N°›</a:t>
             </a:fld>
             <a:endParaRPr lang="en-US"/>
           </a:p>
@@ -1986,7 +1986,7 @@
           <a:p>
             <a:fld id="{5BCAD085-E8A6-8845-BD4E-CB4CCA059FC4}" type="datetimeFigureOut">
               <a:rPr lang="en-US" smtClean="0"/>
-              <a:t>1/27/13</a:t>
+              <a:t>9/14/2026</a:t>
             </a:fld>
             <a:endParaRPr lang="en-US"/>
           </a:p>
@@ -2028,7 +2028,7 @@
           <a:p>
             <a:fld id="{C1FF6DA9-008F-8B48-92A6-B652298478BF}" type="slidenum">
               <a:rPr lang="en-US" smtClean="0"/>
-              <a:t>‹#›</a:t>
+              <a:t>‹N°›</a:t>
             </a:fld>
             <a:endParaRPr lang="en-US"/>
           </a:p>
@@ -2089,10 +2089,9 @@
           </a:lstStyle>
           <a:p>
             <a:r>
-              <a:rPr lang="en-US" smtClean="0"/>
+              <a:rPr lang="en-US"/>
               <a:t>Click to edit Master title style</a:t>
             </a:r>
-            <a:endParaRPr lang="en-US"/>
           </a:p>
         </p:txBody>
       </p:sp>
@@ -2146,38 +2145,37 @@
           <a:p>
             <a:pPr lvl="0"/>
             <a:r>
-              <a:rPr lang="en-US" smtClean="0"/>
+              <a:rPr lang="en-US"/>
               <a:t>Click to edit Master text styles</a:t>
             </a:r>
           </a:p>
           <a:p>
             <a:pPr lvl="1"/>
             <a:r>
-              <a:rPr lang="en-US" smtClean="0"/>
+              <a:rPr lang="en-US"/>
               <a:t>Second level</a:t>
             </a:r>
           </a:p>
           <a:p>
             <a:pPr lvl="2"/>
             <a:r>
-              <a:rPr lang="en-US" smtClean="0"/>
+              <a:rPr lang="en-US"/>
               <a:t>Third level</a:t>
             </a:r>
           </a:p>
           <a:p>
             <a:pPr lvl="3"/>
             <a:r>
-              <a:rPr lang="en-US" smtClean="0"/>
+              <a:rPr lang="en-US"/>
               <a:t>Fourth level</a:t>
             </a:r>
           </a:p>
           <a:p>
             <a:pPr lvl="4"/>
             <a:r>
-              <a:rPr lang="en-US" smtClean="0"/>
+              <a:rPr lang="en-US"/>
               <a:t>Fifth level</a:t>
             </a:r>
-            <a:endParaRPr lang="en-US"/>
           </a:p>
         </p:txBody>
       </p:sp>
@@ -2240,7 +2238,7 @@
           <a:p>
             <a:pPr lvl="0"/>
             <a:r>
-              <a:rPr lang="en-US" smtClean="0"/>
+              <a:rPr lang="en-US"/>
               <a:t>Click to edit Master text styles</a:t>
             </a:r>
           </a:p>
@@ -2263,7 +2261,7 @@
           <a:p>
             <a:fld id="{5BCAD085-E8A6-8845-BD4E-CB4CCA059FC4}" type="datetimeFigureOut">
               <a:rPr lang="en-US" smtClean="0"/>
-              <a:t>1/27/13</a:t>
+              <a:t>9/14/2026</a:t>
             </a:fld>
             <a:endParaRPr lang="en-US"/>
           </a:p>
@@ -2305,7 +2303,7 @@
           <a:p>
             <a:fld id="{C1FF6DA9-008F-8B48-92A6-B652298478BF}" type="slidenum">
               <a:rPr lang="en-US" smtClean="0"/>
-              <a:t>‹#›</a:t>
+              <a:t>‹N°›</a:t>
             </a:fld>
             <a:endParaRPr lang="en-US"/>
           </a:p>
@@ -2366,10 +2364,9 @@
           </a:lstStyle>
           <a:p>
             <a:r>
-              <a:rPr lang="en-US" smtClean="0"/>
+              <a:rPr lang="en-US"/>
               <a:t>Click to edit Master title style</a:t>
             </a:r>
-            <a:endParaRPr lang="en-US"/>
           </a:p>
         </p:txBody>
       </p:sp>
@@ -2493,7 +2490,7 @@
           <a:p>
             <a:pPr lvl="0"/>
             <a:r>
-              <a:rPr lang="en-US" smtClean="0"/>
+              <a:rPr lang="en-US"/>
               <a:t>Click to edit Master text styles</a:t>
             </a:r>
           </a:p>
@@ -2516,7 +2513,7 @@
           <a:p>
             <a:fld id="{5BCAD085-E8A6-8845-BD4E-CB4CCA059FC4}" type="datetimeFigureOut">
               <a:rPr lang="en-US" smtClean="0"/>
-              <a:t>1/27/13</a:t>
+              <a:t>9/14/2026</a:t>
             </a:fld>
             <a:endParaRPr lang="en-US"/>
           </a:p>
@@ -2558,7 +2555,7 @@
           <a:p>
             <a:fld id="{C1FF6DA9-008F-8B48-92A6-B652298478BF}" type="slidenum">
               <a:rPr lang="en-US" smtClean="0"/>
-              <a:t>‹#›</a:t>
+              <a:t>‹N°›</a:t>
             </a:fld>
             <a:endParaRPr lang="en-US"/>
           </a:p>
@@ -2625,10 +2622,9 @@
           <a:lstStyle/>
           <a:p>
             <a:r>
-              <a:rPr lang="en-US" smtClean="0"/>
+              <a:rPr lang="en-US"/>
               <a:t>Click to edit Master title style</a:t>
             </a:r>
-            <a:endParaRPr lang="en-US"/>
           </a:p>
         </p:txBody>
       </p:sp>
@@ -2659,38 +2655,37 @@
           <a:p>
             <a:pPr lvl="0"/>
             <a:r>
-              <a:rPr lang="en-US" smtClean="0"/>
+              <a:rPr lang="en-US"/>
               <a:t>Click to edit Master text styles</a:t>
             </a:r>
           </a:p>
           <a:p>
             <a:pPr lvl="1"/>
             <a:r>
-              <a:rPr lang="en-US" smtClean="0"/>
+              <a:rPr lang="en-US"/>
               <a:t>Second level</a:t>
             </a:r>
           </a:p>
           <a:p>
             <a:pPr lvl="2"/>
             <a:r>
-              <a:rPr lang="en-US" smtClean="0"/>
+              <a:rPr lang="en-US"/>
               <a:t>Third level</a:t>
             </a:r>
           </a:p>
           <a:p>
             <a:pPr lvl="3"/>
             <a:r>
-              <a:rPr lang="en-US" smtClean="0"/>
+              <a:rPr lang="en-US"/>
               <a:t>Fourth level</a:t>
             </a:r>
           </a:p>
           <a:p>
             <a:pPr lvl="4"/>
             <a:r>
-              <a:rPr lang="en-US" smtClean="0"/>
+              <a:rPr lang="en-US"/>
               <a:t>Fifth level</a:t>
             </a:r>
-            <a:endParaRPr lang="en-US"/>
           </a:p>
         </p:txBody>
       </p:sp>
@@ -2729,7 +2724,7 @@
           <a:p>
             <a:fld id="{5BCAD085-E8A6-8845-BD4E-CB4CCA059FC4}" type="datetimeFigureOut">
               <a:rPr lang="en-US" smtClean="0"/>
-              <a:t>1/27/13</a:t>
+              <a:t>9/14/2026</a:t>
             </a:fld>
             <a:endParaRPr lang="en-US"/>
           </a:p>
@@ -2807,7 +2802,7 @@
           <a:p>
             <a:fld id="{C1FF6DA9-008F-8B48-92A6-B652298478BF}" type="slidenum">
               <a:rPr lang="en-US" smtClean="0"/>
-              <a:t>‹#›</a:t>
+              <a:t>‹N°›</a:t>
             </a:fld>
             <a:endParaRPr lang="en-US"/>
           </a:p>
@@ -3088,7 +3083,7 @@
 </file>
 
 <file path=ppt/slides/slide1.xml><?xml version="1.0" encoding="utf-8"?>
-<p:sld xmlns:a="http://schemas.openxmlformats.org/drawingml/2006/main" xmlns:p="http://schemas.openxmlformats.org/presentationml/2006/main" xmlns:r="http://schemas.openxmlformats.org/officeDocument/2006/relationships">
+<p:sld xmlns:a="http://schemas.openxmlformats.org/drawingml/2006/main" xmlns:r="http://schemas.openxmlformats.org/officeDocument/2006/relationships" xmlns:p="http://schemas.openxmlformats.org/presentationml/2006/main">
   <p:cSld>
     <p:spTree>
       <p:nvGrpSpPr>
@@ -3096,7 +3091,14 @@
         <p:cNvGrpSpPr/>
         <p:nvPr/>
       </p:nvGrpSpPr>
-      <p:grpSpPr/>
+      <p:grpSpPr>
+        <a:xfrm>
+          <a:off x="0" y="0"/>
+          <a:ext cx="0" cy="0"/>
+          <a:chOff x="0" y="0"/>
+          <a:chExt cx="0" cy="0"/>
+        </a:xfrm>
+      </p:grpSpPr>
       <p:sp>
         <p:nvSpPr>
           <p:cNvPr id="2" name="Rectangle 1"/>
@@ -3139,6 +3141,7 @@
           <a:lstStyle/>
           <a:p>
             <a:pPr algn="ctr"/>
+            <a:endParaRPr/>
           </a:p>
         </p:txBody>
       </p:sp>
@@ -3182,6 +3185,7 @@
           <a:lstStyle/>
           <a:p>
             <a:pPr algn="ctr"/>
+            <a:endParaRPr/>
           </a:p>
         </p:txBody>
       </p:sp>
@@ -3225,7 +3229,7 @@
         </p:blipFill>
         <p:spPr>
           <a:xfrm>
-            <a:off x="8412480" y="1051560"/>
+            <a:off x="7516741" y="1005840"/>
             <a:ext cx="3566160" cy="685800"/>
           </a:xfrm>
           <a:prstGeom prst="rect">
@@ -3302,16 +3306,6 @@
           </a:p>
           <a:p>
             <a:br/>
-            <a:pPr>
-              <a:spcBef>
-                <a:spcPts val="1200"/>
-              </a:spcBef>
-              <a:defRPr sz="1500">
-                <a:solidFill>
-                  <a:srgbClr val="78828C"/>
-                </a:solidFill>
-              </a:defRPr>
-            </a:pPr>
             <a:r>
               <a:t>Réalisé par : Elias Chakroun &amp; Yahya Khalifi</a:t>
             </a:r>
@@ -3335,7 +3329,7 @@
 </file>
 
 <file path=ppt/slides/slide10.xml><?xml version="1.0" encoding="utf-8"?>
-<p:sld xmlns:a="http://schemas.openxmlformats.org/drawingml/2006/main" xmlns:p="http://schemas.openxmlformats.org/presentationml/2006/main" xmlns:r="http://schemas.openxmlformats.org/officeDocument/2006/relationships">
+<p:sld xmlns:a="http://schemas.openxmlformats.org/drawingml/2006/main" xmlns:r="http://schemas.openxmlformats.org/officeDocument/2006/relationships" xmlns:p="http://schemas.openxmlformats.org/presentationml/2006/main">
   <p:cSld>
     <p:spTree>
       <p:nvGrpSpPr>
@@ -3343,7 +3337,14 @@
         <p:cNvGrpSpPr/>
         <p:nvPr/>
       </p:nvGrpSpPr>
-      <p:grpSpPr/>
+      <p:grpSpPr>
+        <a:xfrm>
+          <a:off x="0" y="0"/>
+          <a:ext cx="0" cy="0"/>
+          <a:chOff x="0" y="0"/>
+          <a:chExt cx="0" cy="0"/>
+        </a:xfrm>
+      </p:grpSpPr>
       <p:sp>
         <p:nvSpPr>
           <p:cNvPr id="2" name="Rectangle 1"/>
@@ -3386,6 +3387,7 @@
           <a:lstStyle/>
           <a:p>
             <a:pPr algn="ctr"/>
+            <a:endParaRPr/>
           </a:p>
         </p:txBody>
       </p:sp>
@@ -3518,7 +3520,7 @@
 </file>
 
 <file path=ppt/slides/slide2.xml><?xml version="1.0" encoding="utf-8"?>
-<p:sld xmlns:a="http://schemas.openxmlformats.org/drawingml/2006/main" xmlns:p="http://schemas.openxmlformats.org/presentationml/2006/main" xmlns:r="http://schemas.openxmlformats.org/officeDocument/2006/relationships">
+<p:sld xmlns:a="http://schemas.openxmlformats.org/drawingml/2006/main" xmlns:r="http://schemas.openxmlformats.org/officeDocument/2006/relationships" xmlns:p="http://schemas.openxmlformats.org/presentationml/2006/main">
   <p:cSld>
     <p:spTree>
       <p:nvGrpSpPr>
@@ -3526,7 +3528,14 @@
         <p:cNvGrpSpPr/>
         <p:nvPr/>
       </p:nvGrpSpPr>
-      <p:grpSpPr/>
+      <p:grpSpPr>
+        <a:xfrm>
+          <a:off x="0" y="0"/>
+          <a:ext cx="0" cy="0"/>
+          <a:chOff x="0" y="0"/>
+          <a:chExt cx="0" cy="0"/>
+        </a:xfrm>
+      </p:grpSpPr>
       <p:sp>
         <p:nvSpPr>
           <p:cNvPr id="2" name="TextBox 1"/>
@@ -3804,7 +3813,7 @@
 </file>
 
 <file path=ppt/slides/slide3.xml><?xml version="1.0" encoding="utf-8"?>
-<p:sld xmlns:a="http://schemas.openxmlformats.org/drawingml/2006/main" xmlns:p="http://schemas.openxmlformats.org/presentationml/2006/main" xmlns:r="http://schemas.openxmlformats.org/officeDocument/2006/relationships">
+<p:sld xmlns:a="http://schemas.openxmlformats.org/drawingml/2006/main" xmlns:r="http://schemas.openxmlformats.org/officeDocument/2006/relationships" xmlns:p="http://schemas.openxmlformats.org/presentationml/2006/main">
   <p:cSld>
     <p:spTree>
       <p:nvGrpSpPr>
@@ -3812,7 +3821,14 @@
         <p:cNvGrpSpPr/>
         <p:nvPr/>
       </p:nvGrpSpPr>
-      <p:grpSpPr/>
+      <p:grpSpPr>
+        <a:xfrm>
+          <a:off x="0" y="0"/>
+          <a:ext cx="0" cy="0"/>
+          <a:chOff x="0" y="0"/>
+          <a:chExt cx="0" cy="0"/>
+        </a:xfrm>
+      </p:grpSpPr>
       <p:sp>
         <p:nvSpPr>
           <p:cNvPr id="2" name="TextBox 1"/>
@@ -4097,7 +4113,7 @@
 </file>
 
 <file path=ppt/slides/slide4.xml><?xml version="1.0" encoding="utf-8"?>
-<p:sld xmlns:a="http://schemas.openxmlformats.org/drawingml/2006/main" xmlns:p="http://schemas.openxmlformats.org/presentationml/2006/main" xmlns:r="http://schemas.openxmlformats.org/officeDocument/2006/relationships">
+<p:sld xmlns:a="http://schemas.openxmlformats.org/drawingml/2006/main" xmlns:r="http://schemas.openxmlformats.org/officeDocument/2006/relationships" xmlns:p="http://schemas.openxmlformats.org/presentationml/2006/main">
   <p:cSld>
     <p:spTree>
       <p:nvGrpSpPr>
@@ -4105,7 +4121,14 @@
         <p:cNvGrpSpPr/>
         <p:nvPr/>
       </p:nvGrpSpPr>
-      <p:grpSpPr/>
+      <p:grpSpPr>
+        <a:xfrm>
+          <a:off x="0" y="0"/>
+          <a:ext cx="0" cy="0"/>
+          <a:chOff x="0" y="0"/>
+          <a:chExt cx="0" cy="0"/>
+        </a:xfrm>
+      </p:grpSpPr>
       <p:sp>
         <p:nvSpPr>
           <p:cNvPr id="2" name="TextBox 1"/>
@@ -4337,8 +4360,8 @@
         </p:nvSpPr>
         <p:spPr>
           <a:xfrm>
-            <a:off x="7315200" y="1645920"/>
-            <a:ext cx="4023360" cy="4206240"/>
+            <a:off x="7589520" y="3784496"/>
+            <a:ext cx="4023360" cy="2166568"/>
           </a:xfrm>
           <a:prstGeom prst="roundRect">
             <a:avLst/>
@@ -4367,7 +4390,7 @@
           </a:fontRef>
         </p:style>
         <p:txBody>
-          <a:bodyPr rtlCol="0" anchor="ctr" wrap="square"/>
+          <a:bodyPr wrap="square" rtlCol="0" anchor="ctr"/>
           <a:lstStyle/>
           <a:p>
             <a:pPr algn="ctr">
@@ -4381,6 +4404,7 @@
               </a:defRPr>
             </a:pPr>
             <a:r>
+              <a:rPr dirty="0"/>
               <a:t>FICHE SIGNALETIQUE</a:t>
             </a:r>
           </a:p>
@@ -4396,7 +4420,12 @@
               </a:defRPr>
             </a:pPr>
             <a:r>
-              <a:t>Création : 1983</a:t>
+              <a:rPr dirty="0" err="1"/>
+              <a:t>Création</a:t>
+            </a:r>
+            <a:r>
+              <a:rPr dirty="0"/>
+              <a:t> : 1983</a:t>
             </a:r>
           </a:p>
           <a:p>
@@ -4411,8 +4440,26 @@
               </a:defRPr>
             </a:pPr>
             <a:r>
-              <a:t>Secteur : Santé / Officines</a:t>
-            </a:r>
+              <a:rPr dirty="0" err="1"/>
+              <a:t>Secteur</a:t>
+            </a:r>
+            <a:r>
+              <a:rPr dirty="0"/>
+              <a:t> : </a:t>
+            </a:r>
+            <a:r>
+              <a:rPr dirty="0" err="1"/>
+              <a:t>Santé</a:t>
+            </a:r>
+            <a:r>
+              <a:rPr dirty="0"/>
+              <a:t> / </a:t>
+            </a:r>
+            <a:r>
+              <a:rPr dirty="0" err="1"/>
+              <a:t>Officines</a:t>
+            </a:r>
+            <a:endParaRPr dirty="0"/>
           </a:p>
           <a:p>
             <a:pPr>
@@ -4426,7 +4473,12 @@
               </a:defRPr>
             </a:pPr>
             <a:r>
-              <a:t>Périmètre : Multi-VPS Nginx</a:t>
+              <a:rPr dirty="0" err="1"/>
+              <a:t>Périmètre</a:t>
+            </a:r>
+            <a:r>
+              <a:rPr dirty="0"/>
+              <a:t> : Multi-VPS Nginx</a:t>
             </a:r>
           </a:p>
           <a:p>
@@ -4441,8 +4493,18 @@
               </a:defRPr>
             </a:pPr>
             <a:r>
-              <a:t>Projet : LogAnalyze</a:t>
-            </a:r>
+              <a:rPr dirty="0" err="1"/>
+              <a:t>Projet</a:t>
+            </a:r>
+            <a:r>
+              <a:rPr dirty="0"/>
+              <a:t> : </a:t>
+            </a:r>
+            <a:r>
+              <a:rPr dirty="0" err="1"/>
+              <a:t>LogAnalyze</a:t>
+            </a:r>
+            <a:endParaRPr dirty="0"/>
           </a:p>
         </p:txBody>
       </p:sp>
@@ -4455,7 +4517,7 @@
 </file>
 
 <file path=ppt/slides/slide5.xml><?xml version="1.0" encoding="utf-8"?>
-<p:sld xmlns:a="http://schemas.openxmlformats.org/drawingml/2006/main" xmlns:p="http://schemas.openxmlformats.org/presentationml/2006/main" xmlns:r="http://schemas.openxmlformats.org/officeDocument/2006/relationships">
+<p:sld xmlns:a="http://schemas.openxmlformats.org/drawingml/2006/main" xmlns:r="http://schemas.openxmlformats.org/officeDocument/2006/relationships" xmlns:p="http://schemas.openxmlformats.org/presentationml/2006/main">
   <p:cSld>
     <p:spTree>
       <p:nvGrpSpPr>
@@ -4463,7 +4525,14 @@
         <p:cNvGrpSpPr/>
         <p:nvPr/>
       </p:nvGrpSpPr>
-      <p:grpSpPr/>
+      <p:grpSpPr>
+        <a:xfrm>
+          <a:off x="0" y="0"/>
+          <a:ext cx="0" cy="0"/>
+          <a:chOff x="0" y="0"/>
+          <a:chExt cx="0" cy="0"/>
+        </a:xfrm>
+      </p:grpSpPr>
       <p:sp>
         <p:nvSpPr>
           <p:cNvPr id="2" name="TextBox 1"/>
@@ -4711,7 +4780,7 @@
 </file>
 
 <file path=ppt/slides/slide6.xml><?xml version="1.0" encoding="utf-8"?>
-<p:sld xmlns:a="http://schemas.openxmlformats.org/drawingml/2006/main" xmlns:p="http://schemas.openxmlformats.org/presentationml/2006/main" xmlns:r="http://schemas.openxmlformats.org/officeDocument/2006/relationships">
+<p:sld xmlns:a="http://schemas.openxmlformats.org/drawingml/2006/main" xmlns:r="http://schemas.openxmlformats.org/officeDocument/2006/relationships" xmlns:p="http://schemas.openxmlformats.org/presentationml/2006/main">
   <p:cSld>
     <p:spTree>
       <p:nvGrpSpPr>
@@ -4719,7 +4788,14 @@
         <p:cNvGrpSpPr/>
         <p:nvPr/>
       </p:nvGrpSpPr>
-      <p:grpSpPr/>
+      <p:grpSpPr>
+        <a:xfrm>
+          <a:off x="0" y="0"/>
+          <a:ext cx="0" cy="0"/>
+          <a:chOff x="0" y="0"/>
+          <a:chExt cx="0" cy="0"/>
+        </a:xfrm>
+      </p:grpSpPr>
       <p:sp>
         <p:nvSpPr>
           <p:cNvPr id="2" name="TextBox 1"/>
@@ -4869,7 +4945,7 @@
         <p:spPr>
           <a:xfrm>
             <a:off x="822960" y="1645920"/>
-            <a:ext cx="5486400" cy="4389120"/>
+            <a:ext cx="5988388" cy="2970044"/>
           </a:xfrm>
           <a:prstGeom prst="rect">
             <a:avLst/>
@@ -4877,7 +4953,7 @@
           <a:noFill/>
         </p:spPr>
         <p:txBody>
-          <a:bodyPr wrap="none">
+          <a:bodyPr wrap="square">
             <a:spAutoFit/>
           </a:bodyPr>
           <a:lstStyle/>
@@ -4893,7 +4969,40 @@
               </a:defRPr>
             </a:pPr>
             <a:r>
-              <a:t>•  Acteur unique : Super-administrateur centralisant la gouvernance technique.</a:t>
+              <a:rPr dirty="0"/>
+              <a:t>•  </a:t>
+            </a:r>
+            <a:r>
+              <a:rPr dirty="0" err="1"/>
+              <a:t>Acteur</a:t>
+            </a:r>
+            <a:r>
+              <a:rPr dirty="0"/>
+              <a:t> unique : Super-</a:t>
+            </a:r>
+            <a:r>
+              <a:rPr dirty="0" err="1"/>
+              <a:t>administrateur</a:t>
+            </a:r>
+            <a:r>
+              <a:rPr dirty="0"/>
+              <a:t> </a:t>
+            </a:r>
+            <a:r>
+              <a:rPr dirty="0" err="1"/>
+              <a:t>centralisant</a:t>
+            </a:r>
+            <a:r>
+              <a:rPr dirty="0"/>
+              <a:t> la </a:t>
+            </a:r>
+            <a:r>
+              <a:rPr dirty="0" err="1"/>
+              <a:t>gouvernance</a:t>
+            </a:r>
+            <a:r>
+              <a:rPr dirty="0"/>
+              <a:t> technique.</a:t>
             </a:r>
           </a:p>
           <a:p>
@@ -4908,7 +5017,56 @@
               </a:defRPr>
             </a:pPr>
             <a:r>
-              <a:t>•  Besoins fonctionnels : Collecte SSH sans agent, déduplication, latences p95/p99, alertes.</a:t>
+              <a:rPr dirty="0"/>
+              <a:t>•  </a:t>
+            </a:r>
+            <a:r>
+              <a:rPr dirty="0" err="1"/>
+              <a:t>Besoins</a:t>
+            </a:r>
+            <a:r>
+              <a:rPr dirty="0"/>
+              <a:t> </a:t>
+            </a:r>
+            <a:r>
+              <a:rPr dirty="0" err="1"/>
+              <a:t>fonctionnels</a:t>
+            </a:r>
+            <a:r>
+              <a:rPr dirty="0"/>
+              <a:t> : </a:t>
+            </a:r>
+            <a:r>
+              <a:rPr dirty="0" err="1"/>
+              <a:t>Collecte</a:t>
+            </a:r>
+            <a:r>
+              <a:rPr dirty="0"/>
+              <a:t> SSH sans agent, </a:t>
+            </a:r>
+            <a:r>
+              <a:rPr dirty="0" err="1"/>
+              <a:t>déduplication</a:t>
+            </a:r>
+            <a:r>
+              <a:rPr dirty="0"/>
+              <a:t>, </a:t>
+            </a:r>
+            <a:r>
+              <a:rPr dirty="0" err="1"/>
+              <a:t>latences</a:t>
+            </a:r>
+            <a:r>
+              <a:rPr dirty="0"/>
+              <a:t> p95/p99, </a:t>
+            </a:r>
+            <a:r>
+              <a:rPr dirty="0" err="1"/>
+              <a:t>alertes</a:t>
+            </a:r>
+            <a:r>
+              <a:rPr dirty="0"/>
+              <a:t>.</a:t>
             </a:r>
           </a:p>
           <a:p>
@@ -4923,7 +5081,40 @@
               </a:defRPr>
             </a:pPr>
             <a:r>
-              <a:t>•  Besoins non fonctionnels : Atomicité ACID, pagination native, chiffrement AES-128.</a:t>
+              <a:rPr dirty="0"/>
+              <a:t>•  </a:t>
+            </a:r>
+            <a:r>
+              <a:rPr dirty="0" err="1"/>
+              <a:t>Besoins</a:t>
+            </a:r>
+            <a:r>
+              <a:rPr dirty="0"/>
+              <a:t> non </a:t>
+            </a:r>
+            <a:r>
+              <a:rPr dirty="0" err="1"/>
+              <a:t>fonctionnels</a:t>
+            </a:r>
+            <a:r>
+              <a:rPr dirty="0"/>
+              <a:t> : </a:t>
+            </a:r>
+            <a:r>
+              <a:rPr dirty="0" err="1"/>
+              <a:t>Atomicité</a:t>
+            </a:r>
+            <a:r>
+              <a:rPr dirty="0"/>
+              <a:t> ACID, pagination native, </a:t>
+            </a:r>
+            <a:r>
+              <a:rPr dirty="0" err="1"/>
+              <a:t>chiffrement</a:t>
+            </a:r>
+            <a:r>
+              <a:rPr dirty="0"/>
+              <a:t> AES-128.</a:t>
             </a:r>
           </a:p>
           <a:p>
@@ -4938,7 +5129,40 @@
               </a:defRPr>
             </a:pPr>
             <a:r>
-              <a:t>•  Modélisation UML : Cas d'utilisation, Classes, Séquence et Activité.</a:t>
+              <a:rPr dirty="0"/>
+              <a:t>•  </a:t>
+            </a:r>
+            <a:r>
+              <a:rPr dirty="0" err="1"/>
+              <a:t>Modélisation</a:t>
+            </a:r>
+            <a:r>
+              <a:rPr dirty="0"/>
+              <a:t> UML : Cas </a:t>
+            </a:r>
+            <a:r>
+              <a:rPr dirty="0" err="1"/>
+              <a:t>d'utilisation</a:t>
+            </a:r>
+            <a:r>
+              <a:rPr dirty="0"/>
+              <a:t>, Classes, </a:t>
+            </a:r>
+            <a:r>
+              <a:rPr dirty="0" err="1"/>
+              <a:t>Séquence</a:t>
+            </a:r>
+            <a:r>
+              <a:rPr dirty="0"/>
+              <a:t> et </a:t>
+            </a:r>
+            <a:r>
+              <a:rPr dirty="0" err="1"/>
+              <a:t>Activité</a:t>
+            </a:r>
+            <a:r>
+              <a:rPr dirty="0"/>
+              <a:t>.</a:t>
             </a:r>
           </a:p>
         </p:txBody>
@@ -4959,8 +5183,8 @@
         </p:blipFill>
         <p:spPr>
           <a:xfrm>
-            <a:off x="6766560" y="1508760"/>
-            <a:ext cx="3501343" cy="4480560"/>
+            <a:off x="6923314" y="1325881"/>
+            <a:ext cx="4752393" cy="4709160"/>
           </a:xfrm>
           <a:prstGeom prst="rect">
             <a:avLst/>
@@ -4976,7 +5200,7 @@
 </file>
 
 <file path=ppt/slides/slide7.xml><?xml version="1.0" encoding="utf-8"?>
-<p:sld xmlns:a="http://schemas.openxmlformats.org/drawingml/2006/main" xmlns:p="http://schemas.openxmlformats.org/presentationml/2006/main" xmlns:r="http://schemas.openxmlformats.org/officeDocument/2006/relationships">
+<p:sld xmlns:a="http://schemas.openxmlformats.org/drawingml/2006/main" xmlns:r="http://schemas.openxmlformats.org/officeDocument/2006/relationships" xmlns:p="http://schemas.openxmlformats.org/presentationml/2006/main">
   <p:cSld>
     <p:spTree>
       <p:nvGrpSpPr>
@@ -4984,7 +5208,14 @@
         <p:cNvGrpSpPr/>
         <p:nvPr/>
       </p:nvGrpSpPr>
-      <p:grpSpPr/>
+      <p:grpSpPr>
+        <a:xfrm>
+          <a:off x="0" y="0"/>
+          <a:ext cx="0" cy="0"/>
+          <a:chOff x="0" y="0"/>
+          <a:chExt cx="0" cy="0"/>
+        </a:xfrm>
+      </p:grpSpPr>
       <p:sp>
         <p:nvSpPr>
           <p:cNvPr id="2" name="TextBox 1"/>
@@ -5247,7 +5478,7 @@
 </file>
 
 <file path=ppt/slides/slide8.xml><?xml version="1.0" encoding="utf-8"?>
-<p:sld xmlns:a="http://schemas.openxmlformats.org/drawingml/2006/main" xmlns:p="http://schemas.openxmlformats.org/presentationml/2006/main" xmlns:r="http://schemas.openxmlformats.org/officeDocument/2006/relationships">
+<p:sld xmlns:a="http://schemas.openxmlformats.org/drawingml/2006/main" xmlns:r="http://schemas.openxmlformats.org/officeDocument/2006/relationships" xmlns:p="http://schemas.openxmlformats.org/presentationml/2006/main">
   <p:cSld>
     <p:spTree>
       <p:nvGrpSpPr>
@@ -5255,7 +5486,14 @@
         <p:cNvGrpSpPr/>
         <p:nvPr/>
       </p:nvGrpSpPr>
-      <p:grpSpPr/>
+      <p:grpSpPr>
+        <a:xfrm>
+          <a:off x="0" y="0"/>
+          <a:ext cx="0" cy="0"/>
+          <a:chOff x="0" y="0"/>
+          <a:chExt cx="0" cy="0"/>
+        </a:xfrm>
+      </p:grpSpPr>
       <p:sp>
         <p:nvSpPr>
           <p:cNvPr id="2" name="TextBox 1"/>
@@ -5490,6 +5728,7 @@
           <a:lstStyle/>
           <a:p>
             <a:pPr algn="ctr"/>
+            <a:endParaRPr/>
           </a:p>
         </p:txBody>
       </p:sp>
@@ -5585,7 +5824,7 @@
 </file>
 
 <file path=ppt/slides/slide9.xml><?xml version="1.0" encoding="utf-8"?>
-<p:sld xmlns:a="http://schemas.openxmlformats.org/drawingml/2006/main" xmlns:p="http://schemas.openxmlformats.org/presentationml/2006/main" xmlns:r="http://schemas.openxmlformats.org/officeDocument/2006/relationships">
+<p:sld xmlns:a="http://schemas.openxmlformats.org/drawingml/2006/main" xmlns:r="http://schemas.openxmlformats.org/officeDocument/2006/relationships" xmlns:p="http://schemas.openxmlformats.org/presentationml/2006/main">
   <p:cSld>
     <p:spTree>
       <p:nvGrpSpPr>
@@ -5593,7 +5832,14 @@
         <p:cNvGrpSpPr/>
         <p:nvPr/>
       </p:nvGrpSpPr>
-      <p:grpSpPr/>
+      <p:grpSpPr>
+        <a:xfrm>
+          <a:off x="0" y="0"/>
+          <a:ext cx="0" cy="0"/>
+          <a:chOff x="0" y="0"/>
+          <a:chExt cx="0" cy="0"/>
+        </a:xfrm>
+      </p:grpSpPr>
       <p:sp>
         <p:nvSpPr>
           <p:cNvPr id="2" name="TextBox 1"/>

</xml_diff>